<commit_message>
docs: author comprehensive product handbook and user manual, add run.py launcher
</commit_message>
<xml_diff>
--- a/presentation/P098_Emotion_Detection.pptx
+++ b/presentation/P098_Emotion_Detection.pptx
@@ -5,16 +5,16 @@
     <p:sldMasterId id="2147483648" r:id="rId1"/>
   </p:sldMasterIdLst>
   <p:sldIdLst>
-    <p:sldId id="256" r:id="rId7"/>
-    <p:sldId id="257" r:id="rId8"/>
-    <p:sldId id="258" r:id="rId9"/>
-    <p:sldId id="259" r:id="rId10"/>
-    <p:sldId id="260" r:id="rId11"/>
-    <p:sldId id="261" r:id="rId12"/>
-    <p:sldId id="262" r:id="rId13"/>
-    <p:sldId id="263" r:id="rId14"/>
-    <p:sldId id="264" r:id="rId15"/>
-    <p:sldId id="265" r:id="rId16"/>
+    <p:sldId id="256" r:id="rId2"/>
+    <p:sldId id="257" r:id="rId3"/>
+    <p:sldId id="258" r:id="rId4"/>
+    <p:sldId id="259" r:id="rId5"/>
+    <p:sldId id="260" r:id="rId6"/>
+    <p:sldId id="261" r:id="rId7"/>
+    <p:sldId id="262" r:id="rId8"/>
+    <p:sldId id="263" r:id="rId9"/>
+    <p:sldId id="264" r:id="rId10"/>
+    <p:sldId id="265" r:id="rId11"/>
   </p:sldIdLst>
   <p:sldSz cx="9144000" cy="6858000" type="screen4x3"/>
   <p:notesSz cx="6858000" cy="9144000"/>
@@ -113,6 +113,22 @@
       </a:defRPr>
     </a:lvl9pPr>
   </p:defaultTextStyle>
+  <p:extLst>
+    <p:ext uri="{EFAFB233-063F-42B5-8137-9DF3F51BA10A}">
+      <p15:sldGuideLst xmlns:p15="http://schemas.microsoft.com/office/powerpoint/2012/main">
+        <p15:guide id="1" orient="horz" pos="2160">
+          <p15:clr>
+            <a:srgbClr val="A4A3A4"/>
+          </p15:clr>
+        </p15:guide>
+        <p15:guide id="2" pos="2880">
+          <p15:clr>
+            <a:srgbClr val="A4A3A4"/>
+          </p15:clr>
+        </p15:guide>
+      </p15:sldGuideLst>
+    </p:ext>
+  </p:extLst>
 </p:presentation>
 </file>
 
@@ -154,10 +170,9 @@
           <a:lstStyle/>
           <a:p>
             <a:r>
-              <a:rPr lang="en-US" smtClean="0"/>
+              <a:rPr lang="en-US"/>
               <a:t>Click to edit Master title style</a:t>
             </a:r>
-            <a:endParaRPr lang="en-US"/>
           </a:p>
         </p:txBody>
       </p:sp>
@@ -273,10 +288,9 @@
           </a:lstStyle>
           <a:p>
             <a:r>
-              <a:rPr lang="en-US" smtClean="0"/>
+              <a:rPr lang="en-US"/>
               <a:t>Click to edit Master subtitle style</a:t>
             </a:r>
-            <a:endParaRPr lang="en-US"/>
           </a:p>
         </p:txBody>
       </p:sp>
@@ -297,7 +311,7 @@
           <a:p>
             <a:fld id="{5BCAD085-E8A6-8845-BD4E-CB4CCA059FC4}" type="datetimeFigureOut">
               <a:rPr lang="en-US" smtClean="0"/>
-              <a:t>1/27/13</a:t>
+              <a:t>10/1/2026</a:t>
             </a:fld>
             <a:endParaRPr lang="en-US"/>
           </a:p>
@@ -391,10 +405,9 @@
           <a:lstStyle/>
           <a:p>
             <a:r>
-              <a:rPr lang="en-US" smtClean="0"/>
+              <a:rPr lang="en-US"/>
               <a:t>Click to edit Master title style</a:t>
             </a:r>
-            <a:endParaRPr lang="en-US"/>
           </a:p>
         </p:txBody>
       </p:sp>
@@ -415,38 +428,37 @@
           <a:p>
             <a:pPr lvl="0"/>
             <a:r>
-              <a:rPr lang="en-US" smtClean="0"/>
+              <a:rPr lang="en-US"/>
               <a:t>Click to edit Master text styles</a:t>
             </a:r>
           </a:p>
           <a:p>
             <a:pPr lvl="1"/>
             <a:r>
-              <a:rPr lang="en-US" smtClean="0"/>
+              <a:rPr lang="en-US"/>
               <a:t>Second level</a:t>
             </a:r>
           </a:p>
           <a:p>
             <a:pPr lvl="2"/>
             <a:r>
-              <a:rPr lang="en-US" smtClean="0"/>
+              <a:rPr lang="en-US"/>
               <a:t>Third level</a:t>
             </a:r>
           </a:p>
           <a:p>
             <a:pPr lvl="3"/>
             <a:r>
-              <a:rPr lang="en-US" smtClean="0"/>
+              <a:rPr lang="en-US"/>
               <a:t>Fourth level</a:t>
             </a:r>
           </a:p>
           <a:p>
             <a:pPr lvl="4"/>
             <a:r>
-              <a:rPr lang="en-US" smtClean="0"/>
+              <a:rPr lang="en-US"/>
               <a:t>Fifth level</a:t>
             </a:r>
-            <a:endParaRPr lang="en-US"/>
           </a:p>
         </p:txBody>
       </p:sp>
@@ -467,7 +479,7 @@
           <a:p>
             <a:fld id="{5BCAD085-E8A6-8845-BD4E-CB4CCA059FC4}" type="datetimeFigureOut">
               <a:rPr lang="en-US" smtClean="0"/>
-              <a:t>1/27/13</a:t>
+              <a:t>10/1/2026</a:t>
             </a:fld>
             <a:endParaRPr lang="en-US"/>
           </a:p>
@@ -566,10 +578,9 @@
           <a:lstStyle/>
           <a:p>
             <a:r>
-              <a:rPr lang="en-US" smtClean="0"/>
+              <a:rPr lang="en-US"/>
               <a:t>Click to edit Master title style</a:t>
             </a:r>
-            <a:endParaRPr lang="en-US"/>
           </a:p>
         </p:txBody>
       </p:sp>
@@ -595,38 +606,37 @@
           <a:p>
             <a:pPr lvl="0"/>
             <a:r>
-              <a:rPr lang="en-US" smtClean="0"/>
+              <a:rPr lang="en-US"/>
               <a:t>Click to edit Master text styles</a:t>
             </a:r>
           </a:p>
           <a:p>
             <a:pPr lvl="1"/>
             <a:r>
-              <a:rPr lang="en-US" smtClean="0"/>
+              <a:rPr lang="en-US"/>
               <a:t>Second level</a:t>
             </a:r>
           </a:p>
           <a:p>
             <a:pPr lvl="2"/>
             <a:r>
-              <a:rPr lang="en-US" smtClean="0"/>
+              <a:rPr lang="en-US"/>
               <a:t>Third level</a:t>
             </a:r>
           </a:p>
           <a:p>
             <a:pPr lvl="3"/>
             <a:r>
-              <a:rPr lang="en-US" smtClean="0"/>
+              <a:rPr lang="en-US"/>
               <a:t>Fourth level</a:t>
             </a:r>
           </a:p>
           <a:p>
             <a:pPr lvl="4"/>
             <a:r>
-              <a:rPr lang="en-US" smtClean="0"/>
+              <a:rPr lang="en-US"/>
               <a:t>Fifth level</a:t>
             </a:r>
-            <a:endParaRPr lang="en-US"/>
           </a:p>
         </p:txBody>
       </p:sp>
@@ -647,7 +657,7 @@
           <a:p>
             <a:fld id="{5BCAD085-E8A6-8845-BD4E-CB4CCA059FC4}" type="datetimeFigureOut">
               <a:rPr lang="en-US" smtClean="0"/>
-              <a:t>1/27/13</a:t>
+              <a:t>10/1/2026</a:t>
             </a:fld>
             <a:endParaRPr lang="en-US"/>
           </a:p>
@@ -741,10 +751,9 @@
           <a:lstStyle/>
           <a:p>
             <a:r>
-              <a:rPr lang="en-US" smtClean="0"/>
+              <a:rPr lang="en-US"/>
               <a:t>Click to edit Master title style</a:t>
             </a:r>
-            <a:endParaRPr lang="en-US"/>
           </a:p>
         </p:txBody>
       </p:sp>
@@ -765,38 +774,37 @@
           <a:p>
             <a:pPr lvl="0"/>
             <a:r>
-              <a:rPr lang="en-US" smtClean="0"/>
+              <a:rPr lang="en-US"/>
               <a:t>Click to edit Master text styles</a:t>
             </a:r>
           </a:p>
           <a:p>
             <a:pPr lvl="1"/>
             <a:r>
-              <a:rPr lang="en-US" smtClean="0"/>
+              <a:rPr lang="en-US"/>
               <a:t>Second level</a:t>
             </a:r>
           </a:p>
           <a:p>
             <a:pPr lvl="2"/>
             <a:r>
-              <a:rPr lang="en-US" smtClean="0"/>
+              <a:rPr lang="en-US"/>
               <a:t>Third level</a:t>
             </a:r>
           </a:p>
           <a:p>
             <a:pPr lvl="3"/>
             <a:r>
-              <a:rPr lang="en-US" smtClean="0"/>
+              <a:rPr lang="en-US"/>
               <a:t>Fourth level</a:t>
             </a:r>
           </a:p>
           <a:p>
             <a:pPr lvl="4"/>
             <a:r>
-              <a:rPr lang="en-US" smtClean="0"/>
+              <a:rPr lang="en-US"/>
               <a:t>Fifth level</a:t>
             </a:r>
-            <a:endParaRPr lang="en-US"/>
           </a:p>
         </p:txBody>
       </p:sp>
@@ -817,7 +825,7 @@
           <a:p>
             <a:fld id="{5BCAD085-E8A6-8845-BD4E-CB4CCA059FC4}" type="datetimeFigureOut">
               <a:rPr lang="en-US" smtClean="0"/>
-              <a:t>1/27/13</a:t>
+              <a:t>10/1/2026</a:t>
             </a:fld>
             <a:endParaRPr lang="en-US"/>
           </a:p>
@@ -920,10 +928,9 @@
           </a:lstStyle>
           <a:p>
             <a:r>
-              <a:rPr lang="en-US" smtClean="0"/>
+              <a:rPr lang="en-US"/>
               <a:t>Click to edit Master title style</a:t>
             </a:r>
-            <a:endParaRPr lang="en-US"/>
           </a:p>
         </p:txBody>
       </p:sp>
@@ -1040,7 +1047,7 @@
           <a:p>
             <a:pPr lvl="0"/>
             <a:r>
-              <a:rPr lang="en-US" smtClean="0"/>
+              <a:rPr lang="en-US"/>
               <a:t>Click to edit Master text styles</a:t>
             </a:r>
           </a:p>
@@ -1063,7 +1070,7 @@
           <a:p>
             <a:fld id="{5BCAD085-E8A6-8845-BD4E-CB4CCA059FC4}" type="datetimeFigureOut">
               <a:rPr lang="en-US" smtClean="0"/>
-              <a:t>1/27/13</a:t>
+              <a:t>10/1/2026</a:t>
             </a:fld>
             <a:endParaRPr lang="en-US"/>
           </a:p>
@@ -1157,10 +1164,9 @@
           <a:lstStyle/>
           <a:p>
             <a:r>
-              <a:rPr lang="en-US" smtClean="0"/>
+              <a:rPr lang="en-US"/>
               <a:t>Click to edit Master title style</a:t>
             </a:r>
-            <a:endParaRPr lang="en-US"/>
           </a:p>
         </p:txBody>
       </p:sp>
@@ -1214,38 +1220,37 @@
           <a:p>
             <a:pPr lvl="0"/>
             <a:r>
-              <a:rPr lang="en-US" smtClean="0"/>
+              <a:rPr lang="en-US"/>
               <a:t>Click to edit Master text styles</a:t>
             </a:r>
           </a:p>
           <a:p>
             <a:pPr lvl="1"/>
             <a:r>
-              <a:rPr lang="en-US" smtClean="0"/>
+              <a:rPr lang="en-US"/>
               <a:t>Second level</a:t>
             </a:r>
           </a:p>
           <a:p>
             <a:pPr lvl="2"/>
             <a:r>
-              <a:rPr lang="en-US" smtClean="0"/>
+              <a:rPr lang="en-US"/>
               <a:t>Third level</a:t>
             </a:r>
           </a:p>
           <a:p>
             <a:pPr lvl="3"/>
             <a:r>
-              <a:rPr lang="en-US" smtClean="0"/>
+              <a:rPr lang="en-US"/>
               <a:t>Fourth level</a:t>
             </a:r>
           </a:p>
           <a:p>
             <a:pPr lvl="4"/>
             <a:r>
-              <a:rPr lang="en-US" smtClean="0"/>
+              <a:rPr lang="en-US"/>
               <a:t>Fifth level</a:t>
             </a:r>
-            <a:endParaRPr lang="en-US"/>
           </a:p>
         </p:txBody>
       </p:sp>
@@ -1299,38 +1304,37 @@
           <a:p>
             <a:pPr lvl="0"/>
             <a:r>
-              <a:rPr lang="en-US" smtClean="0"/>
+              <a:rPr lang="en-US"/>
               <a:t>Click to edit Master text styles</a:t>
             </a:r>
           </a:p>
           <a:p>
             <a:pPr lvl="1"/>
             <a:r>
-              <a:rPr lang="en-US" smtClean="0"/>
+              <a:rPr lang="en-US"/>
               <a:t>Second level</a:t>
             </a:r>
           </a:p>
           <a:p>
             <a:pPr lvl="2"/>
             <a:r>
-              <a:rPr lang="en-US" smtClean="0"/>
+              <a:rPr lang="en-US"/>
               <a:t>Third level</a:t>
             </a:r>
           </a:p>
           <a:p>
             <a:pPr lvl="3"/>
             <a:r>
-              <a:rPr lang="en-US" smtClean="0"/>
+              <a:rPr lang="en-US"/>
               <a:t>Fourth level</a:t>
             </a:r>
           </a:p>
           <a:p>
             <a:pPr lvl="4"/>
             <a:r>
-              <a:rPr lang="en-US" smtClean="0"/>
+              <a:rPr lang="en-US"/>
               <a:t>Fifth level</a:t>
             </a:r>
-            <a:endParaRPr lang="en-US"/>
           </a:p>
         </p:txBody>
       </p:sp>
@@ -1351,7 +1355,7 @@
           <a:p>
             <a:fld id="{5BCAD085-E8A6-8845-BD4E-CB4CCA059FC4}" type="datetimeFigureOut">
               <a:rPr lang="en-US" smtClean="0"/>
-              <a:t>1/27/13</a:t>
+              <a:t>10/1/2026</a:t>
             </a:fld>
             <a:endParaRPr lang="en-US"/>
           </a:p>
@@ -1449,10 +1453,9 @@
           </a:lstStyle>
           <a:p>
             <a:r>
-              <a:rPr lang="en-US" smtClean="0"/>
+              <a:rPr lang="en-US"/>
               <a:t>Click to edit Master title style</a:t>
             </a:r>
-            <a:endParaRPr lang="en-US"/>
           </a:p>
         </p:txBody>
       </p:sp>
@@ -1515,7 +1518,7 @@
           <a:p>
             <a:pPr lvl="0"/>
             <a:r>
-              <a:rPr lang="en-US" smtClean="0"/>
+              <a:rPr lang="en-US"/>
               <a:t>Click to edit Master text styles</a:t>
             </a:r>
           </a:p>
@@ -1571,38 +1574,37 @@
           <a:p>
             <a:pPr lvl="0"/>
             <a:r>
-              <a:rPr lang="en-US" smtClean="0"/>
+              <a:rPr lang="en-US"/>
               <a:t>Click to edit Master text styles</a:t>
             </a:r>
           </a:p>
           <a:p>
             <a:pPr lvl="1"/>
             <a:r>
-              <a:rPr lang="en-US" smtClean="0"/>
+              <a:rPr lang="en-US"/>
               <a:t>Second level</a:t>
             </a:r>
           </a:p>
           <a:p>
             <a:pPr lvl="2"/>
             <a:r>
-              <a:rPr lang="en-US" smtClean="0"/>
+              <a:rPr lang="en-US"/>
               <a:t>Third level</a:t>
             </a:r>
           </a:p>
           <a:p>
             <a:pPr lvl="3"/>
             <a:r>
-              <a:rPr lang="en-US" smtClean="0"/>
+              <a:rPr lang="en-US"/>
               <a:t>Fourth level</a:t>
             </a:r>
           </a:p>
           <a:p>
             <a:pPr lvl="4"/>
             <a:r>
-              <a:rPr lang="en-US" smtClean="0"/>
+              <a:rPr lang="en-US"/>
               <a:t>Fifth level</a:t>
             </a:r>
-            <a:endParaRPr lang="en-US"/>
           </a:p>
         </p:txBody>
       </p:sp>
@@ -1665,7 +1667,7 @@
           <a:p>
             <a:pPr lvl="0"/>
             <a:r>
-              <a:rPr lang="en-US" smtClean="0"/>
+              <a:rPr lang="en-US"/>
               <a:t>Click to edit Master text styles</a:t>
             </a:r>
           </a:p>
@@ -1721,38 +1723,37 @@
           <a:p>
             <a:pPr lvl="0"/>
             <a:r>
-              <a:rPr lang="en-US" smtClean="0"/>
+              <a:rPr lang="en-US"/>
               <a:t>Click to edit Master text styles</a:t>
             </a:r>
           </a:p>
           <a:p>
             <a:pPr lvl="1"/>
             <a:r>
-              <a:rPr lang="en-US" smtClean="0"/>
+              <a:rPr lang="en-US"/>
               <a:t>Second level</a:t>
             </a:r>
           </a:p>
           <a:p>
             <a:pPr lvl="2"/>
             <a:r>
-              <a:rPr lang="en-US" smtClean="0"/>
+              <a:rPr lang="en-US"/>
               <a:t>Third level</a:t>
             </a:r>
           </a:p>
           <a:p>
             <a:pPr lvl="3"/>
             <a:r>
-              <a:rPr lang="en-US" smtClean="0"/>
+              <a:rPr lang="en-US"/>
               <a:t>Fourth level</a:t>
             </a:r>
           </a:p>
           <a:p>
             <a:pPr lvl="4"/>
             <a:r>
-              <a:rPr lang="en-US" smtClean="0"/>
+              <a:rPr lang="en-US"/>
               <a:t>Fifth level</a:t>
             </a:r>
-            <a:endParaRPr lang="en-US"/>
           </a:p>
         </p:txBody>
       </p:sp>
@@ -1773,7 +1774,7 @@
           <a:p>
             <a:fld id="{5BCAD085-E8A6-8845-BD4E-CB4CCA059FC4}" type="datetimeFigureOut">
               <a:rPr lang="en-US" smtClean="0"/>
-              <a:t>1/27/13</a:t>
+              <a:t>10/1/2026</a:t>
             </a:fld>
             <a:endParaRPr lang="en-US"/>
           </a:p>
@@ -1867,10 +1868,9 @@
           <a:lstStyle/>
           <a:p>
             <a:r>
-              <a:rPr lang="en-US" smtClean="0"/>
+              <a:rPr lang="en-US"/>
               <a:t>Click to edit Master title style</a:t>
             </a:r>
-            <a:endParaRPr lang="en-US"/>
           </a:p>
         </p:txBody>
       </p:sp>
@@ -1891,7 +1891,7 @@
           <a:p>
             <a:fld id="{5BCAD085-E8A6-8845-BD4E-CB4CCA059FC4}" type="datetimeFigureOut">
               <a:rPr lang="en-US" smtClean="0"/>
-              <a:t>1/27/13</a:t>
+              <a:t>10/1/2026</a:t>
             </a:fld>
             <a:endParaRPr lang="en-US"/>
           </a:p>
@@ -1986,7 +1986,7 @@
           <a:p>
             <a:fld id="{5BCAD085-E8A6-8845-BD4E-CB4CCA059FC4}" type="datetimeFigureOut">
               <a:rPr lang="en-US" smtClean="0"/>
-              <a:t>1/27/13</a:t>
+              <a:t>10/1/2026</a:t>
             </a:fld>
             <a:endParaRPr lang="en-US"/>
           </a:p>
@@ -2089,10 +2089,9 @@
           </a:lstStyle>
           <a:p>
             <a:r>
-              <a:rPr lang="en-US" smtClean="0"/>
+              <a:rPr lang="en-US"/>
               <a:t>Click to edit Master title style</a:t>
             </a:r>
-            <a:endParaRPr lang="en-US"/>
           </a:p>
         </p:txBody>
       </p:sp>
@@ -2146,38 +2145,37 @@
           <a:p>
             <a:pPr lvl="0"/>
             <a:r>
-              <a:rPr lang="en-US" smtClean="0"/>
+              <a:rPr lang="en-US"/>
               <a:t>Click to edit Master text styles</a:t>
             </a:r>
           </a:p>
           <a:p>
             <a:pPr lvl="1"/>
             <a:r>
-              <a:rPr lang="en-US" smtClean="0"/>
+              <a:rPr lang="en-US"/>
               <a:t>Second level</a:t>
             </a:r>
           </a:p>
           <a:p>
             <a:pPr lvl="2"/>
             <a:r>
-              <a:rPr lang="en-US" smtClean="0"/>
+              <a:rPr lang="en-US"/>
               <a:t>Third level</a:t>
             </a:r>
           </a:p>
           <a:p>
             <a:pPr lvl="3"/>
             <a:r>
-              <a:rPr lang="en-US" smtClean="0"/>
+              <a:rPr lang="en-US"/>
               <a:t>Fourth level</a:t>
             </a:r>
           </a:p>
           <a:p>
             <a:pPr lvl="4"/>
             <a:r>
-              <a:rPr lang="en-US" smtClean="0"/>
+              <a:rPr lang="en-US"/>
               <a:t>Fifth level</a:t>
             </a:r>
-            <a:endParaRPr lang="en-US"/>
           </a:p>
         </p:txBody>
       </p:sp>
@@ -2240,7 +2238,7 @@
           <a:p>
             <a:pPr lvl="0"/>
             <a:r>
-              <a:rPr lang="en-US" smtClean="0"/>
+              <a:rPr lang="en-US"/>
               <a:t>Click to edit Master text styles</a:t>
             </a:r>
           </a:p>
@@ -2263,7 +2261,7 @@
           <a:p>
             <a:fld id="{5BCAD085-E8A6-8845-BD4E-CB4CCA059FC4}" type="datetimeFigureOut">
               <a:rPr lang="en-US" smtClean="0"/>
-              <a:t>1/27/13</a:t>
+              <a:t>10/1/2026</a:t>
             </a:fld>
             <a:endParaRPr lang="en-US"/>
           </a:p>
@@ -2366,10 +2364,9 @@
           </a:lstStyle>
           <a:p>
             <a:r>
-              <a:rPr lang="en-US" smtClean="0"/>
+              <a:rPr lang="en-US"/>
               <a:t>Click to edit Master title style</a:t>
             </a:r>
-            <a:endParaRPr lang="en-US"/>
           </a:p>
         </p:txBody>
       </p:sp>
@@ -2493,7 +2490,7 @@
           <a:p>
             <a:pPr lvl="0"/>
             <a:r>
-              <a:rPr lang="en-US" smtClean="0"/>
+              <a:rPr lang="en-US"/>
               <a:t>Click to edit Master text styles</a:t>
             </a:r>
           </a:p>
@@ -2516,7 +2513,7 @@
           <a:p>
             <a:fld id="{5BCAD085-E8A6-8845-BD4E-CB4CCA059FC4}" type="datetimeFigureOut">
               <a:rPr lang="en-US" smtClean="0"/>
-              <a:t>1/27/13</a:t>
+              <a:t>10/1/2026</a:t>
             </a:fld>
             <a:endParaRPr lang="en-US"/>
           </a:p>
@@ -2625,10 +2622,9 @@
           <a:lstStyle/>
           <a:p>
             <a:r>
-              <a:rPr lang="en-US" smtClean="0"/>
+              <a:rPr lang="en-US"/>
               <a:t>Click to edit Master title style</a:t>
             </a:r>
-            <a:endParaRPr lang="en-US"/>
           </a:p>
         </p:txBody>
       </p:sp>
@@ -2659,38 +2655,37 @@
           <a:p>
             <a:pPr lvl="0"/>
             <a:r>
-              <a:rPr lang="en-US" smtClean="0"/>
+              <a:rPr lang="en-US"/>
               <a:t>Click to edit Master text styles</a:t>
             </a:r>
           </a:p>
           <a:p>
             <a:pPr lvl="1"/>
             <a:r>
-              <a:rPr lang="en-US" smtClean="0"/>
+              <a:rPr lang="en-US"/>
               <a:t>Second level</a:t>
             </a:r>
           </a:p>
           <a:p>
             <a:pPr lvl="2"/>
             <a:r>
-              <a:rPr lang="en-US" smtClean="0"/>
+              <a:rPr lang="en-US"/>
               <a:t>Third level</a:t>
             </a:r>
           </a:p>
           <a:p>
             <a:pPr lvl="3"/>
             <a:r>
-              <a:rPr lang="en-US" smtClean="0"/>
+              <a:rPr lang="en-US"/>
               <a:t>Fourth level</a:t>
             </a:r>
           </a:p>
           <a:p>
             <a:pPr lvl="4"/>
             <a:r>
-              <a:rPr lang="en-US" smtClean="0"/>
+              <a:rPr lang="en-US"/>
               <a:t>Fifth level</a:t>
             </a:r>
-            <a:endParaRPr lang="en-US"/>
           </a:p>
         </p:txBody>
       </p:sp>
@@ -2729,7 +2724,7 @@
           <a:p>
             <a:fld id="{5BCAD085-E8A6-8845-BD4E-CB4CCA059FC4}" type="datetimeFigureOut">
               <a:rPr lang="en-US" smtClean="0"/>
-              <a:t>1/27/13</a:t>
+              <a:t>10/1/2026</a:t>
             </a:fld>
             <a:endParaRPr lang="en-US"/>
           </a:p>
@@ -3088,7 +3083,7 @@
 </file>
 
 <file path=ppt/slides/slide1.xml><?xml version="1.0" encoding="utf-8"?>
-<p:sld xmlns:a="http://schemas.openxmlformats.org/drawingml/2006/main" xmlns:p="http://schemas.openxmlformats.org/presentationml/2006/main" xmlns:r="http://schemas.openxmlformats.org/officeDocument/2006/relationships">
+<p:sld xmlns:a="http://schemas.openxmlformats.org/drawingml/2006/main" xmlns:r="http://schemas.openxmlformats.org/officeDocument/2006/relationships" xmlns:p="http://schemas.openxmlformats.org/presentationml/2006/main">
   <p:cSld>
     <p:spTree>
       <p:nvGrpSpPr>
@@ -3096,7 +3091,14 @@
         <p:cNvGrpSpPr/>
         <p:nvPr/>
       </p:nvGrpSpPr>
-      <p:grpSpPr/>
+      <p:grpSpPr>
+        <a:xfrm>
+          <a:off x="0" y="0"/>
+          <a:ext cx="0" cy="0"/>
+          <a:chOff x="0" y="0"/>
+          <a:chExt cx="0" cy="0"/>
+        </a:xfrm>
+      </p:grpSpPr>
       <p:sp>
         <p:nvSpPr>
           <p:cNvPr id="2" name="TextBox 1"/>
@@ -3106,7 +3108,7 @@
         <p:spPr>
           <a:xfrm>
             <a:off x="731520" y="1645920"/>
-            <a:ext cx="7680960" cy="3657600"/>
+            <a:ext cx="7680960" cy="1779974"/>
           </a:xfrm>
           <a:prstGeom prst="rect">
             <a:avLst/>
@@ -3127,6 +3129,7 @@
               </a:defRPr>
             </a:pPr>
             <a:r>
+              <a:rPr dirty="0"/>
               <a:t>PROJECT P_098</a:t>
             </a:r>
           </a:p>
@@ -3142,6 +3145,7 @@
               </a:defRPr>
             </a:pPr>
             <a:r>
+              <a:rPr dirty="0"/>
               <a:t>Emotion Detection from Text</a:t>
             </a:r>
           </a:p>
@@ -3157,6 +3161,7 @@
               </a:defRPr>
             </a:pPr>
             <a:r>
+              <a:rPr dirty="0"/>
               <a:t>A Hybrid Multi-Engine NLP Architecture with Sarcasm Flagging and Calibrated Uncertainty</a:t>
             </a:r>
           </a:p>
@@ -3169,7 +3174,28 @@
               </a:defRPr>
             </a:pPr>
             <a:r>
-              <a:t>Candidate: Divya  |  HCL Industrial Training  |  Backend: Flask &amp; PyTorch Transformer</a:t>
+              <a:rPr dirty="0"/>
+              <a:t>Candidate: Divya</a:t>
+            </a:r>
+            <a:r>
+              <a:rPr lang="en-IN" dirty="0" err="1"/>
+              <a:t>nsh</a:t>
+            </a:r>
+            <a:r>
+              <a:rPr lang="en-IN" dirty="0"/>
+              <a:t> Yadav</a:t>
+            </a:r>
+            <a:r>
+              <a:rPr dirty="0"/>
+              <a:t>  |  HCL Industrial Training  |  Backend: Flask &amp; </a:t>
+            </a:r>
+            <a:r>
+              <a:rPr dirty="0" err="1"/>
+              <a:t>PyTorch</a:t>
+            </a:r>
+            <a:r>
+              <a:rPr dirty="0"/>
+              <a:t> Transformer</a:t>
             </a:r>
           </a:p>
         </p:txBody>
@@ -3183,7 +3209,7 @@
 </file>
 
 <file path=ppt/slides/slide10.xml><?xml version="1.0" encoding="utf-8"?>
-<p:sld xmlns:a="http://schemas.openxmlformats.org/drawingml/2006/main" xmlns:p="http://schemas.openxmlformats.org/presentationml/2006/main" xmlns:r="http://schemas.openxmlformats.org/officeDocument/2006/relationships">
+<p:sld xmlns:a="http://schemas.openxmlformats.org/drawingml/2006/main" xmlns:r="http://schemas.openxmlformats.org/officeDocument/2006/relationships" xmlns:p="http://schemas.openxmlformats.org/presentationml/2006/main">
   <p:cSld>
     <p:spTree>
       <p:nvGrpSpPr>
@@ -3191,7 +3217,14 @@
         <p:cNvGrpSpPr/>
         <p:nvPr/>
       </p:nvGrpSpPr>
-      <p:grpSpPr/>
+      <p:grpSpPr>
+        <a:xfrm>
+          <a:off x="0" y="0"/>
+          <a:ext cx="0" cy="0"/>
+          <a:chOff x="0" y="0"/>
+          <a:chExt cx="0" cy="0"/>
+        </a:xfrm>
+      </p:grpSpPr>
       <p:sp>
         <p:nvSpPr>
           <p:cNvPr id="2" name="TextBox 1"/>
@@ -3260,7 +3293,9 @@
             <a:spAutoFit/>
           </a:bodyPr>
           <a:lstStyle/>
-          <a:p/>
+          <a:p>
+            <a:endParaRPr/>
+          </a:p>
           <a:p>
             <a:pPr>
               <a:spcAft>
@@ -3364,7 +3399,7 @@
 </file>
 
 <file path=ppt/slides/slide2.xml><?xml version="1.0" encoding="utf-8"?>
-<p:sld xmlns:a="http://schemas.openxmlformats.org/drawingml/2006/main" xmlns:p="http://schemas.openxmlformats.org/presentationml/2006/main" xmlns:r="http://schemas.openxmlformats.org/officeDocument/2006/relationships">
+<p:sld xmlns:a="http://schemas.openxmlformats.org/drawingml/2006/main" xmlns:r="http://schemas.openxmlformats.org/officeDocument/2006/relationships" xmlns:p="http://schemas.openxmlformats.org/presentationml/2006/main">
   <p:cSld>
     <p:spTree>
       <p:nvGrpSpPr>
@@ -3372,7 +3407,14 @@
         <p:cNvGrpSpPr/>
         <p:nvPr/>
       </p:nvGrpSpPr>
-      <p:grpSpPr/>
+      <p:grpSpPr>
+        <a:xfrm>
+          <a:off x="0" y="0"/>
+          <a:ext cx="0" cy="0"/>
+          <a:chOff x="0" y="0"/>
+          <a:chExt cx="0" cy="0"/>
+        </a:xfrm>
+      </p:grpSpPr>
       <p:sp>
         <p:nvSpPr>
           <p:cNvPr id="2" name="TextBox 1"/>
@@ -3441,7 +3483,9 @@
             <a:spAutoFit/>
           </a:bodyPr>
           <a:lstStyle/>
-          <a:p/>
+          <a:p>
+            <a:endParaRPr/>
+          </a:p>
           <a:p>
             <a:pPr>
               <a:spcAft>
@@ -3545,7 +3589,7 @@
 </file>
 
 <file path=ppt/slides/slide3.xml><?xml version="1.0" encoding="utf-8"?>
-<p:sld xmlns:a="http://schemas.openxmlformats.org/drawingml/2006/main" xmlns:p="http://schemas.openxmlformats.org/presentationml/2006/main" xmlns:r="http://schemas.openxmlformats.org/officeDocument/2006/relationships">
+<p:sld xmlns:a="http://schemas.openxmlformats.org/drawingml/2006/main" xmlns:r="http://schemas.openxmlformats.org/officeDocument/2006/relationships" xmlns:p="http://schemas.openxmlformats.org/presentationml/2006/main">
   <p:cSld>
     <p:spTree>
       <p:nvGrpSpPr>
@@ -3553,7 +3597,14 @@
         <p:cNvGrpSpPr/>
         <p:nvPr/>
       </p:nvGrpSpPr>
-      <p:grpSpPr/>
+      <p:grpSpPr>
+        <a:xfrm>
+          <a:off x="0" y="0"/>
+          <a:ext cx="0" cy="0"/>
+          <a:chOff x="0" y="0"/>
+          <a:chExt cx="0" cy="0"/>
+        </a:xfrm>
+      </p:grpSpPr>
       <p:sp>
         <p:nvSpPr>
           <p:cNvPr id="2" name="TextBox 1"/>
@@ -3622,7 +3673,9 @@
             <a:spAutoFit/>
           </a:bodyPr>
           <a:lstStyle/>
-          <a:p/>
+          <a:p>
+            <a:endParaRPr/>
+          </a:p>
           <a:p>
             <a:pPr>
               <a:spcAft>
@@ -3772,7 +3825,7 @@
 </file>
 
 <file path=ppt/slides/slide4.xml><?xml version="1.0" encoding="utf-8"?>
-<p:sld xmlns:a="http://schemas.openxmlformats.org/drawingml/2006/main" xmlns:p="http://schemas.openxmlformats.org/presentationml/2006/main" xmlns:r="http://schemas.openxmlformats.org/officeDocument/2006/relationships">
+<p:sld xmlns:a="http://schemas.openxmlformats.org/drawingml/2006/main" xmlns:r="http://schemas.openxmlformats.org/officeDocument/2006/relationships" xmlns:p="http://schemas.openxmlformats.org/presentationml/2006/main">
   <p:cSld>
     <p:spTree>
       <p:nvGrpSpPr>
@@ -3780,7 +3833,14 @@
         <p:cNvGrpSpPr/>
         <p:nvPr/>
       </p:nvGrpSpPr>
-      <p:grpSpPr/>
+      <p:grpSpPr>
+        <a:xfrm>
+          <a:off x="0" y="0"/>
+          <a:ext cx="0" cy="0"/>
+          <a:chOff x="0" y="0"/>
+          <a:chExt cx="0" cy="0"/>
+        </a:xfrm>
+      </p:grpSpPr>
       <p:sp>
         <p:nvSpPr>
           <p:cNvPr id="2" name="TextBox 1"/>
@@ -3849,7 +3909,9 @@
             <a:spAutoFit/>
           </a:bodyPr>
           <a:lstStyle/>
-          <a:p/>
+          <a:p>
+            <a:endParaRPr/>
+          </a:p>
           <a:p>
             <a:pPr>
               <a:spcAft>
@@ -3953,7 +4015,7 @@
 </file>
 
 <file path=ppt/slides/slide5.xml><?xml version="1.0" encoding="utf-8"?>
-<p:sld xmlns:a="http://schemas.openxmlformats.org/drawingml/2006/main" xmlns:p="http://schemas.openxmlformats.org/presentationml/2006/main" xmlns:r="http://schemas.openxmlformats.org/officeDocument/2006/relationships">
+<p:sld xmlns:a="http://schemas.openxmlformats.org/drawingml/2006/main" xmlns:r="http://schemas.openxmlformats.org/officeDocument/2006/relationships" xmlns:p="http://schemas.openxmlformats.org/presentationml/2006/main">
   <p:cSld>
     <p:spTree>
       <p:nvGrpSpPr>
@@ -3961,7 +4023,14 @@
         <p:cNvGrpSpPr/>
         <p:nvPr/>
       </p:nvGrpSpPr>
-      <p:grpSpPr/>
+      <p:grpSpPr>
+        <a:xfrm>
+          <a:off x="0" y="0"/>
+          <a:ext cx="0" cy="0"/>
+          <a:chOff x="0" y="0"/>
+          <a:chExt cx="0" cy="0"/>
+        </a:xfrm>
+      </p:grpSpPr>
       <p:sp>
         <p:nvSpPr>
           <p:cNvPr id="2" name="TextBox 1"/>
@@ -4030,7 +4099,9 @@
             <a:spAutoFit/>
           </a:bodyPr>
           <a:lstStyle/>
-          <a:p/>
+          <a:p>
+            <a:endParaRPr/>
+          </a:p>
           <a:p>
             <a:pPr>
               <a:spcAft>
@@ -4134,7 +4205,7 @@
 </file>
 
 <file path=ppt/slides/slide6.xml><?xml version="1.0" encoding="utf-8"?>
-<p:sld xmlns:a="http://schemas.openxmlformats.org/drawingml/2006/main" xmlns:p="http://schemas.openxmlformats.org/presentationml/2006/main" xmlns:r="http://schemas.openxmlformats.org/officeDocument/2006/relationships">
+<p:sld xmlns:a="http://schemas.openxmlformats.org/drawingml/2006/main" xmlns:r="http://schemas.openxmlformats.org/officeDocument/2006/relationships" xmlns:p="http://schemas.openxmlformats.org/presentationml/2006/main">
   <p:cSld>
     <p:spTree>
       <p:nvGrpSpPr>
@@ -4142,7 +4213,14 @@
         <p:cNvGrpSpPr/>
         <p:nvPr/>
       </p:nvGrpSpPr>
-      <p:grpSpPr/>
+      <p:grpSpPr>
+        <a:xfrm>
+          <a:off x="0" y="0"/>
+          <a:ext cx="0" cy="0"/>
+          <a:chOff x="0" y="0"/>
+          <a:chExt cx="0" cy="0"/>
+        </a:xfrm>
+      </p:grpSpPr>
       <p:sp>
         <p:nvSpPr>
           <p:cNvPr id="2" name="TextBox 1"/>
@@ -4211,7 +4289,9 @@
             <a:spAutoFit/>
           </a:bodyPr>
           <a:lstStyle/>
-          <a:p/>
+          <a:p>
+            <a:endParaRPr/>
+          </a:p>
           <a:p>
             <a:pPr>
               <a:spcAft>
@@ -4315,7 +4395,7 @@
 </file>
 
 <file path=ppt/slides/slide7.xml><?xml version="1.0" encoding="utf-8"?>
-<p:sld xmlns:a="http://schemas.openxmlformats.org/drawingml/2006/main" xmlns:p="http://schemas.openxmlformats.org/presentationml/2006/main" xmlns:r="http://schemas.openxmlformats.org/officeDocument/2006/relationships">
+<p:sld xmlns:a="http://schemas.openxmlformats.org/drawingml/2006/main" xmlns:r="http://schemas.openxmlformats.org/officeDocument/2006/relationships" xmlns:p="http://schemas.openxmlformats.org/presentationml/2006/main">
   <p:cSld>
     <p:spTree>
       <p:nvGrpSpPr>
@@ -4323,7 +4403,14 @@
         <p:cNvGrpSpPr/>
         <p:nvPr/>
       </p:nvGrpSpPr>
-      <p:grpSpPr/>
+      <p:grpSpPr>
+        <a:xfrm>
+          <a:off x="0" y="0"/>
+          <a:ext cx="0" cy="0"/>
+          <a:chOff x="0" y="0"/>
+          <a:chExt cx="0" cy="0"/>
+        </a:xfrm>
+      </p:grpSpPr>
       <p:sp>
         <p:nvSpPr>
           <p:cNvPr id="2" name="TextBox 1"/>
@@ -4392,7 +4479,9 @@
             <a:spAutoFit/>
           </a:bodyPr>
           <a:lstStyle/>
-          <a:p/>
+          <a:p>
+            <a:endParaRPr/>
+          </a:p>
           <a:p>
             <a:pPr>
               <a:spcAft>
@@ -4496,7 +4585,7 @@
 </file>
 
 <file path=ppt/slides/slide8.xml><?xml version="1.0" encoding="utf-8"?>
-<p:sld xmlns:a="http://schemas.openxmlformats.org/drawingml/2006/main" xmlns:p="http://schemas.openxmlformats.org/presentationml/2006/main" xmlns:r="http://schemas.openxmlformats.org/officeDocument/2006/relationships">
+<p:sld xmlns:a="http://schemas.openxmlformats.org/drawingml/2006/main" xmlns:r="http://schemas.openxmlformats.org/officeDocument/2006/relationships" xmlns:p="http://schemas.openxmlformats.org/presentationml/2006/main">
   <p:cSld>
     <p:spTree>
       <p:nvGrpSpPr>
@@ -4504,7 +4593,14 @@
         <p:cNvGrpSpPr/>
         <p:nvPr/>
       </p:nvGrpSpPr>
-      <p:grpSpPr/>
+      <p:grpSpPr>
+        <a:xfrm>
+          <a:off x="0" y="0"/>
+          <a:ext cx="0" cy="0"/>
+          <a:chOff x="0" y="0"/>
+          <a:chExt cx="0" cy="0"/>
+        </a:xfrm>
+      </p:grpSpPr>
       <p:sp>
         <p:nvSpPr>
           <p:cNvPr id="2" name="TextBox 1"/>
@@ -4573,7 +4669,9 @@
             <a:spAutoFit/>
           </a:bodyPr>
           <a:lstStyle/>
-          <a:p/>
+          <a:p>
+            <a:endParaRPr/>
+          </a:p>
           <a:p>
             <a:pPr>
               <a:spcAft>
@@ -4677,7 +4775,7 @@
 </file>
 
 <file path=ppt/slides/slide9.xml><?xml version="1.0" encoding="utf-8"?>
-<p:sld xmlns:a="http://schemas.openxmlformats.org/drawingml/2006/main" xmlns:p="http://schemas.openxmlformats.org/presentationml/2006/main" xmlns:r="http://schemas.openxmlformats.org/officeDocument/2006/relationships">
+<p:sld xmlns:a="http://schemas.openxmlformats.org/drawingml/2006/main" xmlns:r="http://schemas.openxmlformats.org/officeDocument/2006/relationships" xmlns:p="http://schemas.openxmlformats.org/presentationml/2006/main">
   <p:cSld>
     <p:spTree>
       <p:nvGrpSpPr>
@@ -4685,7 +4783,14 @@
         <p:cNvGrpSpPr/>
         <p:nvPr/>
       </p:nvGrpSpPr>
-      <p:grpSpPr/>
+      <p:grpSpPr>
+        <a:xfrm>
+          <a:off x="0" y="0"/>
+          <a:ext cx="0" cy="0"/>
+          <a:chOff x="0" y="0"/>
+          <a:chExt cx="0" cy="0"/>
+        </a:xfrm>
+      </p:grpSpPr>
       <p:sp>
         <p:nvSpPr>
           <p:cNvPr id="2" name="TextBox 1"/>
@@ -4754,7 +4859,9 @@
             <a:spAutoFit/>
           </a:bodyPr>
           <a:lstStyle/>
-          <a:p/>
+          <a:p>
+            <a:endParaRPr/>
+          </a:p>
           <a:p>
             <a:pPr>
               <a:spcAft>

</xml_diff>